<commit_message>
Presentation: link to sahilsahni18/multicloud-tms
</commit_message>
<xml_diff>
--- a/docs/presentation/TrackFlow-Final-Demo.pptx
+++ b/docs/presentation/TrackFlow-Final-Demo.pptx
@@ -128,14 +128,14 @@
   <p:extLst>
     <p:ext uri="{521415D9-36F7-43E2-AB2F-B90AF26B5E84}">
       <p14:sectionLst xmlns:p14="http://schemas.microsoft.com/office/powerpoint/2010/main">
-        <p14:section name="Introduction" id="{5ae40164-c7b7-f79b-3923-e201f7da322f}">
+        <p14:section name="Introduction" id="{cab32f11-350e-45a7-6abb-001ef6ae0e0e}">
           <p14:sldIdLst>
             <p14:sldId id="256"/>
             <p14:sldId id="257"/>
             <p14:sldId id="258"/>
           </p14:sldIdLst>
         </p14:section>
-        <p14:section name="The application" id="{c3599716-dbee-d08f-7efb-2e7254c9c8c7}">
+        <p14:section name="The application" id="{f1516950-3e9c-4aaa-55d6-fe889b4f200b}">
           <p14:sldIdLst>
             <p14:sldId id="259"/>
             <p14:sldId id="260"/>
@@ -144,7 +144,7 @@
             <p14:sldId id="263"/>
           </p14:sldIdLst>
         </p14:section>
-        <p14:section name="Architecture" id="{0397da7a-29d5-0176-52f9-e14684be4b67}">
+        <p14:section name="Architecture" id="{2a6a73fe-af1d-1f18-dbda-a662797eb2c2}">
           <p14:sldIdLst>
             <p14:sldId id="264"/>
             <p14:sldId id="265"/>
@@ -154,14 +154,14 @@
             <p14:sldId id="269"/>
           </p14:sldIdLst>
         </p14:section>
-        <p14:section name="Deployment Portal" id="{86d51119-ed8b-6df5-8290-58efc584360f}">
+        <p14:section name="Deployment Portal" id="{8a77f0fd-2973-c481-e6d8-dfe34d74211d}">
           <p14:sldIdLst>
             <p14:sldId id="270"/>
             <p14:sldId id="271"/>
             <p14:sldId id="272"/>
           </p14:sldIdLst>
         </p14:section>
-        <p14:section name="Decisions" id="{6f347b46-2934-a056-5189-ba197f610217}">
+        <p14:section name="Decisions" id="{302da3ae-23bf-3308-1ded-5b158f2022b0}">
           <p14:sldIdLst>
             <p14:sldId id="273"/>
             <p14:sldId id="274"/>
@@ -169,7 +169,7 @@
             <p14:sldId id="276"/>
           </p14:sldIdLst>
         </p14:section>
-        <p14:section name="Close" id="{81bc1b9e-3a01-ac63-70c7-d5ceda731842}">
+        <p14:section name="Close" id="{7b43adc8-9745-32a5-a937-741f443951bd}">
           <p14:sldIdLst>
             <p14:sldId id="277"/>
           </p14:sldIdLst>
@@ -3694,7 +3694,7 @@
                   <a:schemeClr val="bg2"/>
                 </a:solidFill>
               </a:rPr>
-              <a:t>github.com/Chetansahney/multicloud-tms</a:t>
+              <a:t>github.com/sahilsahni18/multicloud-tms</a:t>
             </a:r>
             <a:endParaRPr lang="en-US" sz="1400" dirty="0"/>
           </a:p>
@@ -15515,7 +15515,7 @@
                   <a:schemeClr val="bg2"/>
                 </a:solidFill>
               </a:rPr>
-              <a:t>github.com/Chetansahney/multicloud-tms</a:t>
+              <a:t>github.com/sahilsahni18/multicloud-tms</a:t>
             </a:r>
             <a:endParaRPr lang="en-US" sz="1400" dirty="0"/>
           </a:p>

</xml_diff>